<commit_message>
Presentacion final con 36 enlaces al informe: pie por lamina e identificadores de caso y de defecto
</commit_message>
<xml_diff>
--- a/entrega/Proyecto1_Caso3_Grupo5/Proyecto1_Caso3_Grupo5_Exposicion_FINAL.pptx
+++ b/entrega/Proyecto1_Caso3_Grupo5/Proyecto1_Caso3_Grupo5_Exposicion_FINAL.pptx
@@ -2414,6 +2414,10 @@
           </a:solidFill>
           <a:ln/>
         </p:spPr>
+        <p:txBody>
+          <a:bodyPr/>
+          <a:p/>
+        </p:txBody>
       </p:sp>
       <p:sp>
         <p:nvSpPr>
@@ -2706,6 +2710,41 @@
               <a:t>25/09/2026</a:t>
             </a:r>
             <a:endParaRPr lang="en-US" sz="1600" dirty="0"/>
+          </a:p>
+        </p:txBody>
+      </p:sp>
+      <p:sp>
+        <p:nvSpPr>
+          <p:cNvPr id="10" name="TextBox 9"/>
+          <p:cNvSpPr txBox="1"/>
+          <p:nvPr/>
+        </p:nvSpPr>
+        <p:spPr>
+          <a:xfrm>
+            <a:off x="457200" y="6473952"/>
+            <a:ext cx="11277295" cy="256032"/>
+          </a:xfrm>
+          <a:prstGeom prst="rect">
+            <a:avLst/>
+          </a:prstGeom>
+          <a:noFill/>
+        </p:spPr>
+        <p:txBody>
+          <a:bodyPr wrap="none">
+            <a:spAutoFit/>
+          </a:bodyPr>
+          <a:lstStyle/>
+          <a:p>
+            <a:r>
+              <a:rPr sz="1200">
+                <a:solidFill>
+                  <a:srgbClr val="516673"/>
+                </a:solidFill>
+                <a:latin typeface="Arial"/>
+                <a:hlinkClick r:id="rId3"/>
+              </a:rPr>
+              <a:t>▸ Informe integrado · Grupo 5</a:t>
+            </a:r>
           </a:p>
         </p:txBody>
       </p:sp>
@@ -2760,6 +2799,10 @@
           </a:solidFill>
           <a:ln/>
         </p:spPr>
+        <p:txBody>
+          <a:bodyPr/>
+          <a:p/>
+        </p:txBody>
       </p:sp>
       <p:sp>
         <p:nvSpPr>
@@ -2913,6 +2956,10 @@
             <a:prstDash val="solid"/>
           </a:ln>
         </p:spPr>
+        <p:txBody>
+          <a:bodyPr/>
+          <a:p/>
+        </p:txBody>
       </p:sp>
       <p:sp>
         <p:nvSpPr>
@@ -2935,6 +2982,10 @@
           </a:solidFill>
           <a:ln/>
         </p:spPr>
+        <p:txBody>
+          <a:bodyPr/>
+          <a:p/>
+        </p:txBody>
       </p:sp>
       <p:sp>
         <p:nvSpPr>
@@ -3041,6 +3092,10 @@
           </a:solidFill>
           <a:ln/>
         </p:spPr>
+        <p:txBody>
+          <a:bodyPr/>
+          <a:p/>
+        </p:txBody>
       </p:sp>
       <p:sp>
         <p:nvSpPr>
@@ -3152,6 +3207,10 @@
             <a:prstDash val="solid"/>
           </a:ln>
         </p:spPr>
+        <p:txBody>
+          <a:bodyPr/>
+          <a:p/>
+        </p:txBody>
       </p:sp>
       <p:sp>
         <p:nvSpPr>
@@ -3305,6 +3364,10 @@
             <a:prstDash val="solid"/>
           </a:ln>
         </p:spPr>
+        <p:txBody>
+          <a:bodyPr/>
+          <a:p/>
+        </p:txBody>
       </p:sp>
       <p:sp>
         <p:nvSpPr>
@@ -3458,6 +3521,10 @@
             <a:prstDash val="solid"/>
           </a:ln>
         </p:spPr>
+        <p:txBody>
+          <a:bodyPr/>
+          <a:p/>
+        </p:txBody>
       </p:sp>
       <p:sp>
         <p:nvSpPr>
@@ -3611,6 +3678,10 @@
             <a:prstDash val="solid"/>
           </a:ln>
         </p:spPr>
+        <p:txBody>
+          <a:bodyPr/>
+          <a:p/>
+        </p:txBody>
       </p:sp>
       <p:sp>
         <p:nvSpPr>
@@ -3759,6 +3830,10 @@
           </a:solidFill>
           <a:ln/>
         </p:spPr>
+        <p:txBody>
+          <a:bodyPr/>
+          <a:p/>
+        </p:txBody>
       </p:sp>
       <p:sp>
         <p:nvSpPr>
@@ -3841,6 +3916,41 @@
               <a:t>Bloque de Granit · 7 casos Alta:  1 Falló · 6 Bloqueado</a:t>
             </a:r>
             <a:endParaRPr lang="en-US" sz="1500" dirty="0"/>
+          </a:p>
+        </p:txBody>
+      </p:sp>
+      <p:sp>
+        <p:nvSpPr>
+          <p:cNvPr id="32" name="TextBox 31"/>
+          <p:cNvSpPr txBox="1"/>
+          <p:nvPr/>
+        </p:nvSpPr>
+        <p:spPr>
+          <a:xfrm>
+            <a:off x="457200" y="6473952"/>
+            <a:ext cx="11277295" cy="256032"/>
+          </a:xfrm>
+          <a:prstGeom prst="rect">
+            <a:avLst/>
+          </a:prstGeom>
+          <a:noFill/>
+        </p:spPr>
+        <p:txBody>
+          <a:bodyPr wrap="none">
+            <a:spAutoFit/>
+          </a:bodyPr>
+          <a:lstStyle/>
+          <a:p>
+            <a:r>
+              <a:rPr sz="1200">
+                <a:solidFill>
+                  <a:srgbClr val="516673"/>
+                </a:solidFill>
+                <a:latin typeface="Arial"/>
+                <a:hlinkClick r:id="rId3"/>
+              </a:rPr>
+              <a:t>▸ Informe §4.2 Registro de casos Alta · p. 29</a:t>
+            </a:r>
           </a:p>
         </p:txBody>
       </p:sp>
@@ -3895,6 +4005,10 @@
           </a:solidFill>
           <a:ln/>
         </p:spPr>
+        <p:txBody>
+          <a:bodyPr/>
+          <a:p/>
+        </p:txBody>
       </p:sp>
       <p:sp>
         <p:nvSpPr>
@@ -4048,6 +4162,10 @@
             <a:prstDash val="solid"/>
           </a:ln>
         </p:spPr>
+        <p:txBody>
+          <a:bodyPr/>
+          <a:p/>
+        </p:txBody>
       </p:sp>
       <p:sp>
         <p:nvSpPr>
@@ -4395,6 +4513,10 @@
             <a:prstDash val="solid"/>
           </a:ln>
         </p:spPr>
+        <p:txBody>
+          <a:bodyPr/>
+          <a:p/>
+        </p:txBody>
       </p:sp>
       <p:sp>
         <p:nvSpPr>
@@ -4459,6 +4581,10 @@
           </a:solidFill>
           <a:ln/>
         </p:spPr>
+        <p:txBody>
+          <a:bodyPr/>
+          <a:p/>
+        </p:txBody>
       </p:sp>
       <p:sp>
         <p:nvSpPr>
@@ -4607,6 +4733,10 @@
           </a:solidFill>
           <a:ln/>
         </p:spPr>
+        <p:txBody>
+          <a:bodyPr/>
+          <a:p/>
+        </p:txBody>
       </p:sp>
       <p:sp>
         <p:nvSpPr>
@@ -4755,6 +4885,10 @@
           </a:solidFill>
           <a:ln/>
         </p:spPr>
+        <p:txBody>
+          <a:bodyPr/>
+          <a:p/>
+        </p:txBody>
       </p:sp>
       <p:sp>
         <p:nvSpPr>
@@ -4903,6 +5037,10 @@
           </a:solidFill>
           <a:ln/>
         </p:spPr>
+        <p:txBody>
+          <a:bodyPr/>
+          <a:p/>
+        </p:txBody>
       </p:sp>
       <p:sp>
         <p:nvSpPr>
@@ -4943,6 +5081,41 @@
               <a:t>Registro ≠ ejecución.    Ejecución ≠ aprobación.</a:t>
             </a:r>
             <a:endParaRPr lang="en-US" sz="2200" dirty="0"/>
+          </a:p>
+        </p:txBody>
+      </p:sp>
+      <p:sp>
+        <p:nvSpPr>
+          <p:cNvPr id="29" name="TextBox 28"/>
+          <p:cNvSpPr txBox="1"/>
+          <p:nvPr/>
+        </p:nvSpPr>
+        <p:spPr>
+          <a:xfrm>
+            <a:off x="457200" y="6473952"/>
+            <a:ext cx="11277295" cy="256032"/>
+          </a:xfrm>
+          <a:prstGeom prst="rect">
+            <a:avLst/>
+          </a:prstGeom>
+          <a:noFill/>
+        </p:spPr>
+        <p:txBody>
+          <a:bodyPr wrap="none">
+            <a:spAutoFit/>
+          </a:bodyPr>
+          <a:lstStyle/>
+          <a:p>
+            <a:r>
+              <a:rPr sz="1200">
+                <a:solidFill>
+                  <a:srgbClr val="516673"/>
+                </a:solidFill>
+                <a:latin typeface="Arial"/>
+                <a:hlinkClick r:id="rId3"/>
+              </a:rPr>
+              <a:t>▸ Informe §1.4 Criterios de salida · p. 3</a:t>
+            </a:r>
           </a:p>
         </p:txBody>
       </p:sp>
@@ -4997,6 +5170,10 @@
           </a:solidFill>
           <a:ln/>
         </p:spPr>
+        <p:txBody>
+          <a:bodyPr/>
+          <a:p/>
+        </p:txBody>
       </p:sp>
       <p:sp>
         <p:nvSpPr>
@@ -5150,6 +5327,10 @@
             <a:prstDash val="solid"/>
           </a:ln>
         </p:spPr>
+        <p:txBody>
+          <a:bodyPr/>
+          <a:p/>
+        </p:txBody>
       </p:sp>
       <p:sp>
         <p:nvSpPr>
@@ -5214,6 +5395,10 @@
           </a:solidFill>
           <a:ln/>
         </p:spPr>
+        <p:txBody>
+          <a:bodyPr/>
+          <a:p/>
+        </p:txBody>
       </p:sp>
       <p:sp>
         <p:nvSpPr>
@@ -5283,6 +5468,10 @@
             <a:prstDash val="solid"/>
           </a:ln>
         </p:spPr>
+        <p:txBody>
+          <a:bodyPr/>
+          <a:p/>
+        </p:txBody>
       </p:sp>
       <p:sp>
         <p:nvSpPr>
@@ -5347,6 +5536,10 @@
           </a:solidFill>
           <a:ln/>
         </p:spPr>
+        <p:txBody>
+          <a:bodyPr/>
+          <a:p/>
+        </p:txBody>
       </p:sp>
       <p:sp>
         <p:nvSpPr>
@@ -5416,6 +5609,10 @@
             <a:prstDash val="solid"/>
           </a:ln>
         </p:spPr>
+        <p:txBody>
+          <a:bodyPr/>
+          <a:p/>
+        </p:txBody>
       </p:sp>
       <p:sp>
         <p:nvSpPr>
@@ -5480,6 +5677,10 @@
           </a:solidFill>
           <a:ln/>
         </p:spPr>
+        <p:txBody>
+          <a:bodyPr/>
+          <a:p/>
+        </p:txBody>
       </p:sp>
       <p:sp>
         <p:nvSpPr>
@@ -5544,6 +5745,10 @@
           </a:solidFill>
           <a:ln/>
         </p:spPr>
+        <p:txBody>
+          <a:bodyPr/>
+          <a:p/>
+        </p:txBody>
       </p:sp>
       <p:sp>
         <p:nvSpPr>
@@ -5692,6 +5897,10 @@
           </a:solidFill>
           <a:ln/>
         </p:spPr>
+        <p:txBody>
+          <a:bodyPr/>
+          <a:p/>
+        </p:txBody>
       </p:sp>
       <p:sp>
         <p:nvSpPr>
@@ -5840,6 +6049,10 @@
           </a:solidFill>
           <a:ln/>
         </p:spPr>
+        <p:txBody>
+          <a:bodyPr/>
+          <a:p/>
+        </p:txBody>
       </p:sp>
       <p:sp>
         <p:nvSpPr>
@@ -5993,6 +6206,10 @@
             <a:prstDash val="solid"/>
           </a:ln>
         </p:spPr>
+        <p:txBody>
+          <a:bodyPr/>
+          <a:p/>
+        </p:txBody>
       </p:sp>
       <p:sp>
         <p:nvSpPr>
@@ -6050,6 +6267,41 @@
               <a:t>   —diseñadas, no ejecutadas.</a:t>
             </a:r>
             <a:endParaRPr lang="en-US" sz="1700" dirty="0"/>
+          </a:p>
+        </p:txBody>
+      </p:sp>
+      <p:sp>
+        <p:nvSpPr>
+          <p:cNvPr id="32" name="TextBox 31"/>
+          <p:cNvSpPr txBox="1"/>
+          <p:nvPr/>
+        </p:nvSpPr>
+        <p:spPr>
+          <a:xfrm>
+            <a:off x="457200" y="6473952"/>
+            <a:ext cx="11277295" cy="256032"/>
+          </a:xfrm>
+          <a:prstGeom prst="rect">
+            <a:avLst/>
+          </a:prstGeom>
+          <a:noFill/>
+        </p:spPr>
+        <p:txBody>
+          <a:bodyPr wrap="none">
+            <a:spAutoFit/>
+          </a:bodyPr>
+          <a:lstStyle/>
+          <a:p>
+            <a:r>
+              <a:rPr sz="1200">
+                <a:solidFill>
+                  <a:srgbClr val="516673"/>
+                </a:solidFill>
+                <a:latin typeface="Arial"/>
+                <a:hlinkClick r:id="rId3"/>
+              </a:rPr>
+              <a:t>▸ Informe §4.4 Métricas y límites · p. 31</a:t>
+            </a:r>
           </a:p>
         </p:txBody>
       </p:sp>
@@ -6104,6 +6356,10 @@
           </a:solidFill>
           <a:ln/>
         </p:spPr>
+        <p:txBody>
+          <a:bodyPr/>
+          <a:p/>
+        </p:txBody>
       </p:sp>
       <p:sp>
         <p:nvSpPr>
@@ -6420,6 +6676,10 @@
           </a:solidFill>
           <a:ln/>
         </p:spPr>
+        <p:txBody>
+          <a:bodyPr/>
+          <a:p/>
+        </p:txBody>
       </p:sp>
       <p:sp>
         <p:nvSpPr>
@@ -6448,6 +6708,19 @@
               </a:lnSpc>
               <a:buNone/>
             </a:pPr>
+            <a:endParaRPr lang="en-US" sz="1500" dirty="0"/>
+            <a:r>
+              <a:rPr lang="en-US" sz="1500" b="1" dirty="0" u="sng">
+                <a:solidFill>
+                  <a:srgbClr val="007C9F"/>
+                </a:solidFill>
+                <a:latin typeface="Arial" pitchFamily="34" charset="0"/>
+                <a:ea typeface="Arial" pitchFamily="34" charset="-122"/>
+                <a:cs typeface="Arial" pitchFamily="34" charset="-120"/>
+                <a:hlinkClick r:id="rId3"/>
+              </a:rPr>
+              <a:t>DEF-01</a:t>
+            </a:r>
             <a:r>
               <a:rPr lang="en-US" sz="1500" b="1" dirty="0">
                 <a:solidFill>
@@ -6457,9 +6730,8 @@
                 <a:ea typeface="Arial" pitchFamily="34" charset="-122"/>
                 <a:cs typeface="Arial" pitchFamily="34" charset="-120"/>
               </a:rPr>
-              <a:t>DEF-01 · [Carrito] total de línea ≠ total a pagar</a:t>
-            </a:r>
-            <a:endParaRPr lang="en-US" sz="1500" dirty="0"/>
+              <a:t> · [Carrito] total de línea ≠ total a pagar</a:t>
+            </a:r>
           </a:p>
         </p:txBody>
       </p:sp>
@@ -6610,6 +6882,10 @@
           </a:solidFill>
           <a:ln/>
         </p:spPr>
+        <p:txBody>
+          <a:bodyPr/>
+          <a:p/>
+        </p:txBody>
       </p:sp>
       <p:sp>
         <p:nvSpPr>
@@ -6638,6 +6914,19 @@
               </a:lnSpc>
               <a:buNone/>
             </a:pPr>
+            <a:endParaRPr lang="en-US" sz="1500" dirty="0"/>
+            <a:r>
+              <a:rPr lang="en-US" sz="1500" b="1" dirty="0" u="sng">
+                <a:solidFill>
+                  <a:srgbClr val="007C9F"/>
+                </a:solidFill>
+                <a:latin typeface="Arial" pitchFamily="34" charset="0"/>
+                <a:ea typeface="Arial" pitchFamily="34" charset="-122"/>
+                <a:cs typeface="Arial" pitchFamily="34" charset="-120"/>
+                <a:hlinkClick r:id="rId3"/>
+              </a:rPr>
+              <a:t>DEF-04</a:t>
+            </a:r>
             <a:r>
               <a:rPr lang="en-US" sz="1500" b="1" dirty="0">
                 <a:solidFill>
@@ -6647,9 +6936,8 @@
                 <a:ea typeface="Arial" pitchFamily="34" charset="-122"/>
                 <a:cs typeface="Arial" pitchFamily="34" charset="-120"/>
               </a:rPr>
-              <a:t>DEF-04 · [Checkout] sin método de pago aplicable</a:t>
-            </a:r>
-            <a:endParaRPr lang="en-US" sz="1500" dirty="0"/>
+              <a:t> · [Checkout] sin método de pago aplicable</a:t>
+            </a:r>
           </a:p>
         </p:txBody>
       </p:sp>
@@ -6800,6 +7088,10 @@
           </a:solidFill>
           <a:ln/>
         </p:spPr>
+        <p:txBody>
+          <a:bodyPr/>
+          <a:p/>
+        </p:txBody>
       </p:sp>
       <p:sp>
         <p:nvSpPr>
@@ -7037,6 +7329,10 @@
             <a:prstDash val="solid"/>
           </a:ln>
         </p:spPr>
+        <p:txBody>
+          <a:bodyPr/>
+          <a:p/>
+        </p:txBody>
       </p:sp>
       <p:sp>
         <p:nvSpPr>
@@ -7148,6 +7444,10 @@
             <a:prstDash val="solid"/>
           </a:ln>
         </p:spPr>
+        <p:txBody>
+          <a:bodyPr/>
+          <a:p/>
+        </p:txBody>
       </p:sp>
       <p:sp>
         <p:nvSpPr>
@@ -7259,6 +7559,10 @@
             <a:prstDash val="solid"/>
           </a:ln>
         </p:spPr>
+        <p:txBody>
+          <a:bodyPr/>
+          <a:p/>
+        </p:txBody>
       </p:sp>
       <p:sp>
         <p:nvSpPr>
@@ -7370,6 +7674,10 @@
             <a:prstDash val="solid"/>
           </a:ln>
         </p:spPr>
+        <p:txBody>
+          <a:bodyPr/>
+          <a:p/>
+        </p:txBody>
       </p:sp>
       <p:sp>
         <p:nvSpPr>
@@ -7481,6 +7789,10 @@
             <a:prstDash val="solid"/>
           </a:ln>
         </p:spPr>
+        <p:txBody>
+          <a:bodyPr/>
+          <a:p/>
+        </p:txBody>
       </p:sp>
       <p:sp>
         <p:nvSpPr>
@@ -7587,6 +7899,10 @@
           </a:solidFill>
           <a:ln/>
         </p:spPr>
+        <p:txBody>
+          <a:bodyPr/>
+          <a:p/>
+        </p:txBody>
       </p:sp>
       <p:sp>
         <p:nvSpPr>
@@ -7652,6 +7968,10 @@
             <a:prstDash val="solid"/>
           </a:ln>
         </p:spPr>
+        <p:txBody>
+          <a:bodyPr/>
+          <a:p/>
+        </p:txBody>
       </p:sp>
       <p:sp>
         <p:nvSpPr>
@@ -7675,6 +7995,10 @@
             <a:prstDash val="solid"/>
           </a:ln>
         </p:spPr>
+        <p:txBody>
+          <a:bodyPr/>
+          <a:p/>
+        </p:txBody>
       </p:sp>
       <p:sp>
         <p:nvSpPr>
@@ -7697,6 +8021,10 @@
           </a:solidFill>
           <a:ln/>
         </p:spPr>
+        <p:txBody>
+          <a:bodyPr/>
+          <a:p/>
+        </p:txBody>
       </p:sp>
       <p:sp>
         <p:nvSpPr>
@@ -7761,6 +8089,10 @@
           </a:solidFill>
           <a:ln/>
         </p:spPr>
+        <p:txBody>
+          <a:bodyPr/>
+          <a:p/>
+        </p:txBody>
       </p:sp>
       <p:sp>
         <p:nvSpPr>
@@ -7919,6 +8251,41 @@
               <a:t>que la corrección no rompa lo relacionado.</a:t>
             </a:r>
             <a:endParaRPr lang="en-US" sz="1500" dirty="0"/>
+          </a:p>
+        </p:txBody>
+      </p:sp>
+      <p:sp>
+        <p:nvSpPr>
+          <p:cNvPr id="51" name="TextBox 50"/>
+          <p:cNvSpPr txBox="1"/>
+          <p:nvPr/>
+        </p:nvSpPr>
+        <p:spPr>
+          <a:xfrm>
+            <a:off x="457200" y="6473952"/>
+            <a:ext cx="11277295" cy="256032"/>
+          </a:xfrm>
+          <a:prstGeom prst="rect">
+            <a:avLst/>
+          </a:prstGeom>
+          <a:noFill/>
+        </p:spPr>
+        <p:txBody>
+          <a:bodyPr wrap="none">
+            <a:spAutoFit/>
+          </a:bodyPr>
+          <a:lstStyle/>
+          <a:p>
+            <a:r>
+              <a:rPr sz="1200">
+                <a:solidFill>
+                  <a:srgbClr val="516673"/>
+                </a:solidFill>
+                <a:latin typeface="Arial"/>
+                <a:hlinkClick r:id="rId3"/>
+              </a:rPr>
+              <a:t>▸ Informe §4.5 Hallazgos · p. 32</a:t>
+            </a:r>
           </a:p>
         </p:txBody>
       </p:sp>
@@ -7973,6 +8340,10 @@
           </a:solidFill>
           <a:ln/>
         </p:spPr>
+        <p:txBody>
+          <a:bodyPr/>
+          <a:p/>
+        </p:txBody>
       </p:sp>
       <p:sp>
         <p:nvSpPr>
@@ -8126,6 +8497,10 @@
             <a:prstDash val="solid"/>
           </a:ln>
         </p:spPr>
+        <p:txBody>
+          <a:bodyPr/>
+          <a:p/>
+        </p:txBody>
       </p:sp>
       <p:sp>
         <p:nvSpPr>
@@ -8146,6 +8521,10 @@
           </a:solidFill>
           <a:ln/>
         </p:spPr>
+        <p:txBody>
+          <a:bodyPr/>
+          <a:p/>
+        </p:txBody>
       </p:sp>
       <p:sp>
         <p:nvSpPr>
@@ -8217,13 +8596,14 @@
               <a:buNone/>
             </a:pPr>
             <a:r>
-              <a:rPr lang="en-US" sz="1900" b="1" dirty="0">
-                <a:solidFill>
-                  <a:srgbClr val="142D3D"/>
-                </a:solidFill>
-                <a:latin typeface="Arial" pitchFamily="34" charset="0"/>
-                <a:ea typeface="Arial" pitchFamily="34" charset="-122"/>
-                <a:cs typeface="Arial" pitchFamily="34" charset="-120"/>
+              <a:rPr lang="en-US" sz="1900" b="1" dirty="0" u="sng">
+                <a:solidFill>
+                  <a:srgbClr val="007C9F"/>
+                </a:solidFill>
+                <a:latin typeface="Arial" pitchFamily="34" charset="0"/>
+                <a:ea typeface="Arial" pitchFamily="34" charset="-122"/>
+                <a:cs typeface="Arial" pitchFamily="34" charset="-120"/>
+                <a:hlinkClick r:id="rId3"/>
               </a:rPr>
               <a:t>CP-CAR-01</a:t>
             </a:r>
@@ -8299,6 +8679,10 @@
             <a:prstDash val="solid"/>
           </a:ln>
         </p:spPr>
+        <p:txBody>
+          <a:bodyPr/>
+          <a:p/>
+        </p:txBody>
       </p:sp>
       <p:sp>
         <p:nvSpPr>
@@ -8319,6 +8703,10 @@
           </a:solidFill>
           <a:ln/>
         </p:spPr>
+        <p:txBody>
+          <a:bodyPr/>
+          <a:p/>
+        </p:txBody>
       </p:sp>
       <p:sp>
         <p:nvSpPr>
@@ -8390,13 +8778,14 @@
               <a:buNone/>
             </a:pPr>
             <a:r>
-              <a:rPr lang="en-US" sz="1900" b="1" dirty="0">
-                <a:solidFill>
-                  <a:srgbClr val="142D3D"/>
-                </a:solidFill>
-                <a:latin typeface="Arial" pitchFamily="34" charset="0"/>
-                <a:ea typeface="Arial" pitchFamily="34" charset="-122"/>
-                <a:cs typeface="Arial" pitchFamily="34" charset="-120"/>
+              <a:rPr lang="en-US" sz="1900" b="1" dirty="0" u="sng">
+                <a:solidFill>
+                  <a:srgbClr val="007C9F"/>
+                </a:solidFill>
+                <a:latin typeface="Arial" pitchFamily="34" charset="0"/>
+                <a:ea typeface="Arial" pitchFamily="34" charset="-122"/>
+                <a:cs typeface="Arial" pitchFamily="34" charset="-120"/>
+                <a:hlinkClick r:id="rId4"/>
               </a:rPr>
               <a:t>CP-CAT-02</a:t>
             </a:r>
@@ -8472,6 +8861,10 @@
             <a:prstDash val="solid"/>
           </a:ln>
         </p:spPr>
+        <p:txBody>
+          <a:bodyPr/>
+          <a:p/>
+        </p:txBody>
       </p:sp>
       <p:sp>
         <p:nvSpPr>
@@ -8492,6 +8885,10 @@
           </a:solidFill>
           <a:ln/>
         </p:spPr>
+        <p:txBody>
+          <a:bodyPr/>
+          <a:p/>
+        </p:txBody>
       </p:sp>
       <p:sp>
         <p:nvSpPr>
@@ -8563,13 +8960,14 @@
               <a:buNone/>
             </a:pPr>
             <a:r>
-              <a:rPr lang="en-US" sz="1900" b="1" dirty="0">
-                <a:solidFill>
-                  <a:srgbClr val="142D3D"/>
-                </a:solidFill>
-                <a:latin typeface="Arial" pitchFamily="34" charset="0"/>
-                <a:ea typeface="Arial" pitchFamily="34" charset="-122"/>
-                <a:cs typeface="Arial" pitchFamily="34" charset="-120"/>
+              <a:rPr lang="en-US" sz="1900" b="1" dirty="0" u="sng">
+                <a:solidFill>
+                  <a:srgbClr val="007C9F"/>
+                </a:solidFill>
+                <a:latin typeface="Arial" pitchFamily="34" charset="0"/>
+                <a:ea typeface="Arial" pitchFamily="34" charset="-122"/>
+                <a:cs typeface="Arial" pitchFamily="34" charset="-120"/>
+                <a:hlinkClick r:id="rId5"/>
               </a:rPr>
               <a:t>CP-PRO-01</a:t>
             </a:r>
@@ -8640,6 +9038,10 @@
           </a:solidFill>
           <a:ln/>
         </p:spPr>
+        <p:txBody>
+          <a:bodyPr/>
+          <a:p/>
+        </p:txBody>
       </p:sp>
       <p:sp>
         <p:nvSpPr>
@@ -8710,6 +9112,19 @@
               </a:lnSpc>
               <a:buNone/>
             </a:pPr>
+            <a:endParaRPr lang="en-US" sz="1500" dirty="0"/>
+            <a:r>
+              <a:rPr lang="en-US" sz="1500" dirty="0" u="sng">
+                <a:solidFill>
+                  <a:srgbClr val="007C9F"/>
+                </a:solidFill>
+                <a:latin typeface="Arial" pitchFamily="34" charset="0"/>
+                <a:ea typeface="Arial" pitchFamily="34" charset="-122"/>
+                <a:cs typeface="Arial" pitchFamily="34" charset="-120"/>
+                <a:hlinkClick r:id="rId6"/>
+              </a:rPr>
+              <a:t>CP-CAR-02</a:t>
+            </a:r>
             <a:r>
               <a:rPr lang="en-US" sz="1500" dirty="0">
                 <a:solidFill>
@@ -8719,9 +9134,8 @@
                 <a:ea typeface="Arial" pitchFamily="34" charset="-122"/>
                 <a:cs typeface="Arial" pitchFamily="34" charset="-120"/>
               </a:rPr>
-              <a:t>CP-CAR-02: fijar y restaurar el stock · cupones vigentes · pedidos: pago de prueba y permisos.</a:t>
-            </a:r>
-            <a:endParaRPr lang="en-US" sz="1500" dirty="0"/>
+              <a:t>: fijar y restaurar el stock · cupones vigentes · pedidos: pago de prueba y permisos.</a:t>
+            </a:r>
           </a:p>
         </p:txBody>
       </p:sp>
@@ -8746,6 +9160,10 @@
           </a:solidFill>
           <a:ln/>
         </p:spPr>
+        <p:txBody>
+          <a:bodyPr/>
+          <a:p/>
+        </p:txBody>
       </p:sp>
       <p:sp>
         <p:nvSpPr>
@@ -8857,6 +9275,10 @@
             <a:prstDash val="solid"/>
           </a:ln>
         </p:spPr>
+        <p:txBody>
+          <a:bodyPr/>
+          <a:p/>
+        </p:txBody>
       </p:sp>
       <p:sp>
         <p:nvSpPr>
@@ -8914,6 +9336,41 @@
               <a:t>Automatizar un flujo nunca completado a mano da pruebas que fallan por el bloqueo conocido.</a:t>
             </a:r>
             <a:endParaRPr lang="en-US" sz="1600" dirty="0"/>
+          </a:p>
+        </p:txBody>
+      </p:sp>
+      <p:sp>
+        <p:nvSpPr>
+          <p:cNvPr id="29" name="TextBox 28"/>
+          <p:cNvSpPr txBox="1"/>
+          <p:nvPr/>
+        </p:nvSpPr>
+        <p:spPr>
+          <a:xfrm>
+            <a:off x="457200" y="6473952"/>
+            <a:ext cx="11277295" cy="256032"/>
+          </a:xfrm>
+          <a:prstGeom prst="rect">
+            <a:avLst/>
+          </a:prstGeom>
+          <a:noFill/>
+        </p:spPr>
+        <p:txBody>
+          <a:bodyPr wrap="none">
+            <a:spAutoFit/>
+          </a:bodyPr>
+          <a:lstStyle/>
+          <a:p>
+            <a:r>
+              <a:rPr sz="1200">
+                <a:solidFill>
+                  <a:srgbClr val="516673"/>
+                </a:solidFill>
+                <a:latin typeface="Arial"/>
+                <a:hlinkClick r:id="rId7"/>
+              </a:rPr>
+              <a:t>▸ Informe §5.2 Automatización · p. 35</a:t>
+            </a:r>
           </a:p>
         </p:txBody>
       </p:sp>
@@ -8968,6 +9425,10 @@
           </a:solidFill>
           <a:ln/>
         </p:spPr>
+        <p:txBody>
+          <a:bodyPr/>
+          <a:p/>
+        </p:txBody>
       </p:sp>
       <p:sp>
         <p:nvSpPr>
@@ -9121,6 +9582,10 @@
             <a:prstDash val="solid"/>
           </a:ln>
         </p:spPr>
+        <p:txBody>
+          <a:bodyPr/>
+          <a:p/>
+        </p:txBody>
       </p:sp>
       <p:sp>
         <p:nvSpPr>
@@ -9274,6 +9739,10 @@
             <a:prstDash val="solid"/>
           </a:ln>
         </p:spPr>
+        <p:txBody>
+          <a:bodyPr/>
+          <a:p/>
+        </p:txBody>
       </p:sp>
       <p:sp>
         <p:nvSpPr>
@@ -9427,6 +9896,10 @@
             <a:prstDash val="solid"/>
           </a:ln>
         </p:spPr>
+        <p:txBody>
+          <a:bodyPr/>
+          <a:p/>
+        </p:txBody>
       </p:sp>
       <p:sp>
         <p:nvSpPr>
@@ -9575,6 +10048,10 @@
           </a:solidFill>
           <a:ln/>
         </p:spPr>
+        <p:txBody>
+          <a:bodyPr/>
+          <a:p/>
+        </p:txBody>
       </p:sp>
       <p:sp>
         <p:nvSpPr>
@@ -9597,6 +10074,10 @@
           </a:solidFill>
           <a:ln/>
         </p:spPr>
+        <p:txBody>
+          <a:bodyPr/>
+          <a:p/>
+        </p:txBody>
       </p:sp>
       <p:sp>
         <p:nvSpPr>
@@ -9708,6 +10189,10 @@
             <a:prstDash val="solid"/>
           </a:ln>
         </p:spPr>
+        <p:txBody>
+          <a:bodyPr/>
+          <a:p/>
+        </p:txBody>
       </p:sp>
       <p:sp>
         <p:nvSpPr>
@@ -9748,6 +10233,41 @@
               <a:t>Así un cambio en los datos del demo no se confunde con una corrección del sistema.</a:t>
             </a:r>
             <a:endParaRPr lang="en-US" sz="1700" dirty="0"/>
+          </a:p>
+        </p:txBody>
+      </p:sp>
+      <p:sp>
+        <p:nvSpPr>
+          <p:cNvPr id="24" name="TextBox 23"/>
+          <p:cNvSpPr txBox="1"/>
+          <p:nvPr/>
+        </p:nvSpPr>
+        <p:spPr>
+          <a:xfrm>
+            <a:off x="457200" y="6473952"/>
+            <a:ext cx="11277295" cy="256032"/>
+          </a:xfrm>
+          <a:prstGeom prst="rect">
+            <a:avLst/>
+          </a:prstGeom>
+          <a:noFill/>
+        </p:spPr>
+        <p:txBody>
+          <a:bodyPr wrap="none">
+            <a:spAutoFit/>
+          </a:bodyPr>
+          <a:lstStyle/>
+          <a:p>
+            <a:r>
+              <a:rPr sz="1200">
+                <a:solidFill>
+                  <a:srgbClr val="516673"/>
+                </a:solidFill>
+                <a:latin typeface="Arial"/>
+                <a:hlinkClick r:id="rId3"/>
+              </a:rPr>
+              <a:t>▸ Informe §5.1 Conclusión · p. 35</a:t>
+            </a:r>
           </a:p>
         </p:txBody>
       </p:sp>
@@ -9802,6 +10322,10 @@
           </a:solidFill>
           <a:ln/>
         </p:spPr>
+        <p:txBody>
+          <a:bodyPr/>
+          <a:p/>
+        </p:txBody>
       </p:sp>
       <p:sp>
         <p:nvSpPr>
@@ -9950,6 +10474,10 @@
           </a:solidFill>
           <a:ln/>
         </p:spPr>
+        <p:txBody>
+          <a:bodyPr/>
+          <a:p/>
+        </p:txBody>
       </p:sp>
       <p:sp>
         <p:nvSpPr>
@@ -10056,6 +10584,10 @@
           </a:solidFill>
           <a:ln/>
         </p:spPr>
+        <p:txBody>
+          <a:bodyPr/>
+          <a:p/>
+        </p:txBody>
       </p:sp>
       <p:sp>
         <p:nvSpPr>
@@ -10162,6 +10694,10 @@
           </a:solidFill>
           <a:ln/>
         </p:spPr>
+        <p:txBody>
+          <a:bodyPr/>
+          <a:p/>
+        </p:txBody>
       </p:sp>
       <p:sp>
         <p:nvSpPr>
@@ -10232,6 +10768,7 @@
               </a:lnSpc>
               <a:buNone/>
             </a:pPr>
+            <a:endParaRPr lang="en-US" sz="1500" dirty="0"/>
             <a:r>
               <a:rPr lang="en-US" sz="1500" dirty="0">
                 <a:solidFill>
@@ -10241,9 +10778,43 @@
                 <a:ea typeface="Arial" pitchFamily="34" charset="-122"/>
                 <a:cs typeface="Arial" pitchFamily="34" charset="-120"/>
               </a:rPr>
-              <a:t>defectos abiertos: DEF-01 y DEF-04</a:t>
-            </a:r>
-            <a:endParaRPr lang="en-US" sz="1500" dirty="0"/>
+              <a:t>defectos abiertos: </a:t>
+            </a:r>
+            <a:r>
+              <a:rPr lang="en-US" sz="1500" dirty="0" u="sng">
+                <a:solidFill>
+                  <a:srgbClr val="007C9F"/>
+                </a:solidFill>
+                <a:latin typeface="Arial" pitchFamily="34" charset="0"/>
+                <a:ea typeface="Arial" pitchFamily="34" charset="-122"/>
+                <a:cs typeface="Arial" pitchFamily="34" charset="-120"/>
+                <a:hlinkClick r:id="rId3"/>
+              </a:rPr>
+              <a:t>DEF-01</a:t>
+            </a:r>
+            <a:r>
+              <a:rPr lang="en-US" sz="1500" dirty="0">
+                <a:solidFill>
+                  <a:srgbClr val="C7D6DE"/>
+                </a:solidFill>
+                <a:latin typeface="Arial" pitchFamily="34" charset="0"/>
+                <a:ea typeface="Arial" pitchFamily="34" charset="-122"/>
+                <a:cs typeface="Arial" pitchFamily="34" charset="-120"/>
+              </a:rPr>
+              <a:t> y </a:t>
+            </a:r>
+            <a:r>
+              <a:rPr lang="en-US" sz="1500" dirty="0" u="sng">
+                <a:solidFill>
+                  <a:srgbClr val="007C9F"/>
+                </a:solidFill>
+                <a:latin typeface="Arial" pitchFamily="34" charset="0"/>
+                <a:ea typeface="Arial" pitchFamily="34" charset="-122"/>
+                <a:cs typeface="Arial" pitchFamily="34" charset="-120"/>
+                <a:hlinkClick r:id="rId3"/>
+              </a:rPr>
+              <a:t>DEF-04</a:t>
+            </a:r>
           </a:p>
         </p:txBody>
       </p:sp>
@@ -10268,6 +10839,10 @@
           </a:solidFill>
           <a:ln/>
         </p:spPr>
+        <p:txBody>
+          <a:bodyPr/>
+          <a:p/>
+        </p:txBody>
       </p:sp>
       <p:sp>
         <p:nvSpPr>
@@ -10434,6 +11009,41 @@
               <a:t>El ambiente donde se prueba es parte del trabajo, no un supuesto.</a:t>
             </a:r>
             <a:endParaRPr lang="en-US" sz="1700" dirty="0"/>
+          </a:p>
+        </p:txBody>
+      </p:sp>
+      <p:sp>
+        <p:nvSpPr>
+          <p:cNvPr id="20" name="TextBox 19"/>
+          <p:cNvSpPr txBox="1"/>
+          <p:nvPr/>
+        </p:nvSpPr>
+        <p:spPr>
+          <a:xfrm>
+            <a:off x="457200" y="6473952"/>
+            <a:ext cx="11277295" cy="256032"/>
+          </a:xfrm>
+          <a:prstGeom prst="rect">
+            <a:avLst/>
+          </a:prstGeom>
+          <a:noFill/>
+        </p:spPr>
+        <p:txBody>
+          <a:bodyPr wrap="none">
+            <a:spAutoFit/>
+          </a:bodyPr>
+          <a:lstStyle/>
+          <a:p>
+            <a:r>
+              <a:rPr sz="1200">
+                <a:solidFill>
+                  <a:srgbClr val="516673"/>
+                </a:solidFill>
+                <a:latin typeface="Arial"/>
+                <a:hlinkClick r:id="rId4"/>
+              </a:rPr>
+              <a:t>▸ Informe §5.1 Conclusión · p. 35</a:t>
+            </a:r>
           </a:p>
         </p:txBody>
       </p:sp>
@@ -10490,6 +11100,10 @@
           </a:solidFill>
           <a:ln/>
         </p:spPr>
+        <p:txBody>
+          <a:bodyPr/>
+          <a:p/>
+        </p:txBody>
       </p:sp>
       <p:sp>
         <p:nvSpPr>
@@ -10640,6 +11254,10 @@
             <a:prstDash val="solid"/>
           </a:ln>
         </p:spPr>
+        <p:txBody>
+          <a:bodyPr/>
+          <a:p/>
+        </p:txBody>
       </p:sp>
       <p:sp>
         <p:nvSpPr>
@@ -10706,6 +11324,10 @@
             <a:prstDash val="solid"/>
           </a:ln>
         </p:spPr>
+        <p:txBody>
+          <a:bodyPr/>
+          <a:p/>
+        </p:txBody>
       </p:sp>
       <p:sp>
         <p:nvSpPr>
@@ -10772,6 +11394,10 @@
             <a:prstDash val="solid"/>
           </a:ln>
         </p:spPr>
+        <p:txBody>
+          <a:bodyPr/>
+          <a:p/>
+        </p:txBody>
       </p:sp>
       <p:sp>
         <p:nvSpPr>
@@ -10854,6 +11480,41 @@
               <a:t>Proyecto 1 · Caso 3 · OpenCart Demo 4.0.2.3 · 25/09/2026</a:t>
             </a:r>
             <a:endParaRPr lang="en-US" sz="1500" dirty="0"/>
+          </a:p>
+        </p:txBody>
+      </p:sp>
+      <p:sp>
+        <p:nvSpPr>
+          <p:cNvPr id="13" name="TextBox 12"/>
+          <p:cNvSpPr txBox="1"/>
+          <p:nvPr/>
+        </p:nvSpPr>
+        <p:spPr>
+          <a:xfrm>
+            <a:off x="457200" y="6473952"/>
+            <a:ext cx="11277295" cy="256032"/>
+          </a:xfrm>
+          <a:prstGeom prst="rect">
+            <a:avLst/>
+          </a:prstGeom>
+          <a:noFill/>
+        </p:spPr>
+        <p:txBody>
+          <a:bodyPr wrap="none">
+            <a:spAutoFit/>
+          </a:bodyPr>
+          <a:lstStyle/>
+          <a:p>
+            <a:r>
+              <a:rPr sz="1200">
+                <a:solidFill>
+                  <a:srgbClr val="516673"/>
+                </a:solidFill>
+                <a:latin typeface="Arial"/>
+                <a:hlinkClick r:id="rId3"/>
+              </a:rPr>
+              <a:t>▸ Informe integrado · Grupo 5</a:t>
+            </a:r>
           </a:p>
         </p:txBody>
       </p:sp>
@@ -10908,6 +11569,10 @@
           </a:solidFill>
           <a:ln/>
         </p:spPr>
+        <p:txBody>
+          <a:bodyPr/>
+          <a:p/>
+        </p:txBody>
       </p:sp>
       <p:sp>
         <p:nvSpPr>
@@ -11061,6 +11726,10 @@
             <a:prstDash val="solid"/>
           </a:ln>
         </p:spPr>
+        <p:txBody>
+          <a:bodyPr/>
+          <a:p/>
+        </p:txBody>
       </p:sp>
       <p:sp>
         <p:nvSpPr>
@@ -11281,6 +11950,10 @@
             <a:prstDash val="solid"/>
           </a:ln>
         </p:spPr>
+        <p:txBody>
+          <a:bodyPr/>
+          <a:p/>
+        </p:txBody>
       </p:sp>
       <p:sp>
         <p:nvSpPr>
@@ -11501,6 +12174,10 @@
             <a:prstDash val="solid"/>
           </a:ln>
         </p:spPr>
+        <p:txBody>
+          <a:bodyPr/>
+          <a:p/>
+        </p:txBody>
       </p:sp>
       <p:sp>
         <p:nvSpPr>
@@ -11716,6 +12393,10 @@
           </a:solidFill>
           <a:ln/>
         </p:spPr>
+        <p:txBody>
+          <a:bodyPr/>
+          <a:p/>
+        </p:txBody>
       </p:sp>
       <p:sp>
         <p:nvSpPr>
@@ -11738,6 +12419,10 @@
           </a:solidFill>
           <a:ln/>
         </p:spPr>
+        <p:txBody>
+          <a:bodyPr/>
+          <a:p/>
+        </p:txBody>
       </p:sp>
       <p:sp>
         <p:nvSpPr>
@@ -11862,6 +12547,41 @@
               <a:t>Estimación: 24 horas, con reserva por bloqueos.</a:t>
             </a:r>
             <a:endParaRPr lang="en-US" sz="1500" dirty="0"/>
+          </a:p>
+        </p:txBody>
+      </p:sp>
+      <p:sp>
+        <p:nvSpPr>
+          <p:cNvPr id="20" name="TextBox 19"/>
+          <p:cNvSpPr txBox="1"/>
+          <p:nvPr/>
+        </p:nvSpPr>
+        <p:spPr>
+          <a:xfrm>
+            <a:off x="457200" y="6473952"/>
+            <a:ext cx="11277295" cy="256032"/>
+          </a:xfrm>
+          <a:prstGeom prst="rect">
+            <a:avLst/>
+          </a:prstGeom>
+          <a:noFill/>
+        </p:spPr>
+        <p:txBody>
+          <a:bodyPr wrap="none">
+            <a:spAutoFit/>
+          </a:bodyPr>
+          <a:lstStyle/>
+          <a:p>
+            <a:r>
+              <a:rPr sz="1200">
+                <a:solidFill>
+                  <a:srgbClr val="516673"/>
+                </a:solidFill>
+                <a:latin typeface="Arial"/>
+                <a:hlinkClick r:id="rId3"/>
+              </a:rPr>
+              <a:t>▸ Informe §1.2 Alcance · p. 2</a:t>
+            </a:r>
           </a:p>
         </p:txBody>
       </p:sp>
@@ -11916,6 +12636,10 @@
           </a:solidFill>
           <a:ln/>
         </p:spPr>
+        <p:txBody>
+          <a:bodyPr/>
+          <a:p/>
+        </p:txBody>
       </p:sp>
       <p:sp>
         <p:nvSpPr>
@@ -12321,6 +13045,10 @@
             <a:prstDash val="solid"/>
           </a:ln>
         </p:spPr>
+        <p:txBody>
+          <a:bodyPr/>
+          <a:p/>
+        </p:txBody>
       </p:sp>
       <p:sp>
         <p:nvSpPr>
@@ -12390,6 +13118,10 @@
             <a:prstDash val="solid"/>
           </a:ln>
         </p:spPr>
+        <p:txBody>
+          <a:bodyPr/>
+          <a:p/>
+        </p:txBody>
       </p:sp>
       <p:sp>
         <p:nvSpPr>
@@ -12459,6 +13191,10 @@
             <a:prstDash val="solid"/>
           </a:ln>
         </p:spPr>
+        <p:txBody>
+          <a:bodyPr/>
+          <a:p/>
+        </p:txBody>
       </p:sp>
       <p:sp>
         <p:nvSpPr>
@@ -12570,6 +13306,10 @@
             <a:prstDash val="solid"/>
           </a:ln>
         </p:spPr>
+        <p:txBody>
+          <a:bodyPr/>
+          <a:p/>
+        </p:txBody>
       </p:sp>
       <p:sp>
         <p:nvSpPr>
@@ -12639,6 +13379,10 @@
             <a:prstDash val="solid"/>
           </a:ln>
         </p:spPr>
+        <p:txBody>
+          <a:bodyPr/>
+          <a:p/>
+        </p:txBody>
       </p:sp>
       <p:sp>
         <p:nvSpPr>
@@ -12708,6 +13452,10 @@
             <a:prstDash val="solid"/>
           </a:ln>
         </p:spPr>
+        <p:txBody>
+          <a:bodyPr/>
+          <a:p/>
+        </p:txBody>
       </p:sp>
       <p:sp>
         <p:nvSpPr>
@@ -12819,6 +13567,10 @@
             <a:prstDash val="solid"/>
           </a:ln>
         </p:spPr>
+        <p:txBody>
+          <a:bodyPr/>
+          <a:p/>
+        </p:txBody>
       </p:sp>
       <p:sp>
         <p:nvSpPr>
@@ -12888,6 +13640,10 @@
             <a:prstDash val="solid"/>
           </a:ln>
         </p:spPr>
+        <p:txBody>
+          <a:bodyPr/>
+          <a:p/>
+        </p:txBody>
       </p:sp>
       <p:sp>
         <p:nvSpPr>
@@ -12957,6 +13713,10 @@
             <a:prstDash val="solid"/>
           </a:ln>
         </p:spPr>
+        <p:txBody>
+          <a:bodyPr/>
+          <a:p/>
+        </p:txBody>
       </p:sp>
       <p:sp>
         <p:nvSpPr>
@@ -13068,6 +13828,10 @@
             <a:prstDash val="solid"/>
           </a:ln>
         </p:spPr>
+        <p:txBody>
+          <a:bodyPr/>
+          <a:p/>
+        </p:txBody>
       </p:sp>
       <p:sp>
         <p:nvSpPr>
@@ -13219,6 +13983,10 @@
             <a:prstDash val="solid"/>
           </a:ln>
         </p:spPr>
+        <p:txBody>
+          <a:bodyPr/>
+          <a:p/>
+        </p:txBody>
       </p:sp>
       <p:sp>
         <p:nvSpPr>
@@ -13283,6 +14051,10 @@
           </a:solidFill>
           <a:ln/>
         </p:spPr>
+        <p:txBody>
+          <a:bodyPr/>
+          <a:p/>
+        </p:txBody>
       </p:sp>
       <p:sp>
         <p:nvSpPr>
@@ -13347,6 +14119,10 @@
           </a:solidFill>
           <a:ln/>
         </p:spPr>
+        <p:txBody>
+          <a:bodyPr/>
+          <a:p/>
+        </p:txBody>
       </p:sp>
       <p:sp>
         <p:nvSpPr>
@@ -13411,6 +14187,10 @@
           </a:solidFill>
           <a:ln/>
         </p:spPr>
+        <p:txBody>
+          <a:bodyPr/>
+          <a:p/>
+        </p:txBody>
       </p:sp>
       <p:sp>
         <p:nvSpPr>
@@ -13475,6 +14255,10 @@
           </a:solidFill>
           <a:ln/>
         </p:spPr>
+        <p:txBody>
+          <a:bodyPr/>
+          <a:p/>
+        </p:txBody>
       </p:sp>
       <p:sp>
         <p:nvSpPr>
@@ -13599,6 +14383,41 @@
               <a:t>14 casos de prioridad Alta · 4 de prioridad Media</a:t>
             </a:r>
             <a:endParaRPr lang="en-US" sz="1500" dirty="0"/>
+          </a:p>
+        </p:txBody>
+      </p:sp>
+      <p:sp>
+        <p:nvSpPr>
+          <p:cNvPr id="48" name="TextBox 47"/>
+          <p:cNvSpPr txBox="1"/>
+          <p:nvPr/>
+        </p:nvSpPr>
+        <p:spPr>
+          <a:xfrm>
+            <a:off x="457200" y="6473952"/>
+            <a:ext cx="11277295" cy="256032"/>
+          </a:xfrm>
+          <a:prstGeom prst="rect">
+            <a:avLst/>
+          </a:prstGeom>
+          <a:noFill/>
+        </p:spPr>
+        <p:txBody>
+          <a:bodyPr wrap="none">
+            <a:spAutoFit/>
+          </a:bodyPr>
+          <a:lstStyle/>
+          <a:p>
+            <a:r>
+              <a:rPr sz="1200">
+                <a:solidFill>
+                  <a:srgbClr val="516673"/>
+                </a:solidFill>
+                <a:latin typeface="Arial"/>
+                <a:hlinkClick r:id="rId3"/>
+              </a:rPr>
+              <a:t>▸ Informe §1.6 Riesgos de producto · p. 4</a:t>
+            </a:r>
           </a:p>
         </p:txBody>
       </p:sp>
@@ -13653,6 +14472,10 @@
           </a:solidFill>
           <a:ln/>
         </p:spPr>
+        <p:txBody>
+          <a:bodyPr/>
+          <a:p/>
+        </p:txBody>
       </p:sp>
       <p:sp>
         <p:nvSpPr>
@@ -13806,6 +14629,10 @@
             <a:prstDash val="solid"/>
           </a:ln>
         </p:spPr>
+        <p:txBody>
+          <a:bodyPr/>
+          <a:p/>
+        </p:txBody>
       </p:sp>
       <p:sp>
         <p:nvSpPr>
@@ -13828,6 +14655,10 @@
           </a:solidFill>
           <a:ln/>
         </p:spPr>
+        <p:txBody>
+          <a:bodyPr/>
+          <a:p/>
+        </p:txBody>
       </p:sp>
       <p:sp>
         <p:nvSpPr>
@@ -13981,6 +14812,10 @@
             <a:prstDash val="solid"/>
           </a:ln>
         </p:spPr>
+        <p:txBody>
+          <a:bodyPr/>
+          <a:p/>
+        </p:txBody>
       </p:sp>
       <p:sp>
         <p:nvSpPr>
@@ -14003,6 +14838,10 @@
           </a:solidFill>
           <a:ln/>
         </p:spPr>
+        <p:txBody>
+          <a:bodyPr/>
+          <a:p/>
+        </p:txBody>
       </p:sp>
       <p:sp>
         <p:nvSpPr>
@@ -14073,6 +14912,19 @@
               </a:lnSpc>
               <a:buNone/>
             </a:pPr>
+            <a:endParaRPr lang="en-US" sz="1600" dirty="0"/>
+            <a:r>
+              <a:rPr lang="en-US" sz="1600" dirty="0" u="sng">
+                <a:solidFill>
+                  <a:srgbClr val="007C9F"/>
+                </a:solidFill>
+                <a:latin typeface="Arial" pitchFamily="34" charset="0"/>
+                <a:ea typeface="Arial" pitchFamily="34" charset="-122"/>
+                <a:cs typeface="Arial" pitchFamily="34" charset="-120"/>
+                <a:hlinkClick r:id="rId3"/>
+              </a:rPr>
+              <a:t>CP-CAR-01</a:t>
+            </a:r>
             <a:r>
               <a:rPr lang="en-US" sz="1600" dirty="0">
                 <a:solidFill>
@@ -14082,9 +14934,8 @@
                 <a:ea typeface="Arial" pitchFamily="34" charset="-122"/>
                 <a:cs typeface="Arial" pitchFamily="34" charset="-120"/>
               </a:rPr>
-              <a:t>CP-CAR-01 · iPod Nano, 1 → 2 unidades</a:t>
-            </a:r>
-            <a:endParaRPr lang="en-US" sz="1600" dirty="0"/>
+              <a:t> · iPod Nano, 1 → 2 unidades</a:t>
+            </a:r>
           </a:p>
         </p:txBody>
       </p:sp>
@@ -14156,6 +15007,10 @@
             <a:prstDash val="solid"/>
           </a:ln>
         </p:spPr>
+        <p:txBody>
+          <a:bodyPr/>
+          <a:p/>
+        </p:txBody>
       </p:sp>
       <p:sp>
         <p:nvSpPr>
@@ -14178,6 +15033,10 @@
           </a:solidFill>
           <a:ln/>
         </p:spPr>
+        <p:txBody>
+          <a:bodyPr/>
+          <a:p/>
+        </p:txBody>
       </p:sp>
       <p:sp>
         <p:nvSpPr>
@@ -14331,6 +15190,10 @@
             <a:prstDash val="solid"/>
           </a:ln>
         </p:spPr>
+        <p:txBody>
+          <a:bodyPr/>
+          <a:p/>
+        </p:txBody>
       </p:sp>
       <p:sp>
         <p:nvSpPr>
@@ -14353,6 +15216,10 @@
           </a:solidFill>
           <a:ln/>
         </p:spPr>
+        <p:txBody>
+          <a:bodyPr/>
+          <a:p/>
+        </p:txBody>
       </p:sp>
       <p:sp>
         <p:nvSpPr>
@@ -14423,6 +15290,19 @@
               </a:lnSpc>
               <a:buNone/>
             </a:pPr>
+            <a:endParaRPr lang="en-US" sz="1600" dirty="0"/>
+            <a:r>
+              <a:rPr lang="en-US" sz="1600" dirty="0" u="sng">
+                <a:solidFill>
+                  <a:srgbClr val="007C9F"/>
+                </a:solidFill>
+                <a:latin typeface="Arial" pitchFamily="34" charset="0"/>
+                <a:ea typeface="Arial" pitchFamily="34" charset="-122"/>
+                <a:cs typeface="Arial" pitchFamily="34" charset="-120"/>
+                <a:hlinkClick r:id="rId4"/>
+              </a:rPr>
+              <a:t>DEF-01</a:t>
+            </a:r>
             <a:r>
               <a:rPr lang="en-US" sz="1600" dirty="0">
                 <a:solidFill>
@@ -14432,9 +15312,8 @@
                 <a:ea typeface="Arial" pitchFamily="34" charset="-122"/>
                 <a:cs typeface="Arial" pitchFamily="34" charset="-120"/>
               </a:rPr>
-              <a:t>DEF-01 · Abierto</a:t>
-            </a:r>
-            <a:endParaRPr lang="en-US" sz="1600" dirty="0"/>
+              <a:t> · Abierto</a:t>
+            </a:r>
           </a:p>
         </p:txBody>
       </p:sp>
@@ -14501,6 +15380,10 @@
           </a:solidFill>
           <a:ln/>
         </p:spPr>
+        <p:txBody>
+          <a:bodyPr/>
+          <a:p/>
+        </p:txBody>
       </p:sp>
       <p:sp>
         <p:nvSpPr>
@@ -14523,6 +15406,10 @@
           </a:solidFill>
           <a:ln/>
         </p:spPr>
+        <p:txBody>
+          <a:bodyPr/>
+          <a:p/>
+        </p:txBody>
       </p:sp>
       <p:sp>
         <p:nvSpPr>
@@ -14647,6 +15534,41 @@
               <a:t>Justifica la prioridad y devuelve a la evidencia.</a:t>
             </a:r>
             <a:endParaRPr lang="en-US" sz="1500" dirty="0"/>
+          </a:p>
+        </p:txBody>
+      </p:sp>
+      <p:sp>
+        <p:nvSpPr>
+          <p:cNvPr id="31" name="TextBox 30"/>
+          <p:cNvSpPr txBox="1"/>
+          <p:nvPr/>
+        </p:nvSpPr>
+        <p:spPr>
+          <a:xfrm>
+            <a:off x="457200" y="6473952"/>
+            <a:ext cx="11277295" cy="256032"/>
+          </a:xfrm>
+          <a:prstGeom prst="rect">
+            <a:avLst/>
+          </a:prstGeom>
+          <a:noFill/>
+        </p:spPr>
+        <p:txBody>
+          <a:bodyPr wrap="none">
+            <a:spAutoFit/>
+          </a:bodyPr>
+          <a:lstStyle/>
+          <a:p>
+            <a:r>
+              <a:rPr sz="1200">
+                <a:solidFill>
+                  <a:srgbClr val="516673"/>
+                </a:solidFill>
+                <a:latin typeface="Arial"/>
+                <a:hlinkClick r:id="rId5"/>
+              </a:rPr>
+              <a:t>▸ Informe §2.1 Cobertura y trazabilidad · p. 7</a:t>
+            </a:r>
           </a:p>
         </p:txBody>
       </p:sp>
@@ -14701,6 +15623,10 @@
           </a:solidFill>
           <a:ln/>
         </p:spPr>
+        <p:txBody>
+          <a:bodyPr/>
+          <a:p/>
+        </p:txBody>
       </p:sp>
       <p:sp>
         <p:nvSpPr>
@@ -14933,6 +15859,10 @@
           </a:solidFill>
           <a:ln/>
         </p:spPr>
+        <p:txBody>
+          <a:bodyPr/>
+          <a:p/>
+        </p:txBody>
       </p:sp>
       <p:sp>
         <p:nvSpPr>
@@ -15039,6 +15969,10 @@
           </a:solidFill>
           <a:ln/>
         </p:spPr>
+        <p:txBody>
+          <a:bodyPr/>
+          <a:p/>
+        </p:txBody>
       </p:sp>
       <p:sp>
         <p:nvSpPr>
@@ -15145,6 +16079,10 @@
           </a:solidFill>
           <a:ln/>
         </p:spPr>
+        <p:txBody>
+          <a:bodyPr/>
+          <a:p/>
+        </p:txBody>
       </p:sp>
       <p:sp>
         <p:nvSpPr>
@@ -15251,6 +16189,10 @@
           </a:solidFill>
           <a:ln/>
         </p:spPr>
+        <p:txBody>
+          <a:bodyPr/>
+          <a:p/>
+        </p:txBody>
       </p:sp>
       <p:sp>
         <p:nvSpPr>
@@ -15357,6 +16299,10 @@
           </a:solidFill>
           <a:ln/>
         </p:spPr>
+        <p:txBody>
+          <a:bodyPr/>
+          <a:p/>
+        </p:txBody>
       </p:sp>
       <p:sp>
         <p:nvSpPr>
@@ -15463,6 +16409,10 @@
           </a:solidFill>
           <a:ln/>
         </p:spPr>
+        <p:txBody>
+          <a:bodyPr/>
+          <a:p/>
+        </p:txBody>
       </p:sp>
       <p:sp>
         <p:nvSpPr>
@@ -15485,6 +16435,10 @@
           </a:solidFill>
           <a:ln/>
         </p:spPr>
+        <p:txBody>
+          <a:bodyPr/>
+          <a:p/>
+        </p:txBody>
       </p:sp>
       <p:sp>
         <p:nvSpPr>
@@ -15567,6 +16521,41 @@
               <a:t>Justifican el diseño, no la verificación.</a:t>
             </a:r>
             <a:endParaRPr lang="en-US" sz="1700" dirty="0"/>
+          </a:p>
+        </p:txBody>
+      </p:sp>
+      <p:sp>
+        <p:nvSpPr>
+          <p:cNvPr id="27" name="TextBox 26"/>
+          <p:cNvSpPr txBox="1"/>
+          <p:nvPr/>
+        </p:nvSpPr>
+        <p:spPr>
+          <a:xfrm>
+            <a:off x="457200" y="6473952"/>
+            <a:ext cx="11277295" cy="256032"/>
+          </a:xfrm>
+          <a:prstGeom prst="rect">
+            <a:avLst/>
+          </a:prstGeom>
+          <a:noFill/>
+        </p:spPr>
+        <p:txBody>
+          <a:bodyPr wrap="none">
+            <a:spAutoFit/>
+          </a:bodyPr>
+          <a:lstStyle/>
+          <a:p>
+            <a:r>
+              <a:rPr sz="1200">
+                <a:solidFill>
+                  <a:srgbClr val="516673"/>
+                </a:solidFill>
+                <a:latin typeface="Arial"/>
+                <a:hlinkClick r:id="rId3"/>
+              </a:rPr>
+              <a:t>▸ Informe §3.1 Técnicas y oráculos · p. 9</a:t>
+            </a:r>
           </a:p>
         </p:txBody>
       </p:sp>
@@ -15621,6 +16610,10 @@
           </a:solidFill>
           <a:ln/>
         </p:spPr>
+        <p:txBody>
+          <a:bodyPr/>
+          <a:p/>
+        </p:txBody>
       </p:sp>
       <p:sp>
         <p:nvSpPr>
@@ -15774,6 +16767,10 @@
             <a:prstDash val="solid"/>
           </a:ln>
         </p:spPr>
+        <p:txBody>
+          <a:bodyPr/>
+          <a:p/>
+        </p:txBody>
       </p:sp>
       <p:sp>
         <p:nvSpPr>
@@ -15796,6 +16793,10 @@
           </a:solidFill>
           <a:ln/>
         </p:spPr>
+        <p:txBody>
+          <a:bodyPr/>
+          <a:p/>
+        </p:txBody>
       </p:sp>
       <p:sp>
         <p:nvSpPr>
@@ -15867,13 +16868,14 @@
               <a:buNone/>
             </a:pPr>
             <a:r>
-              <a:rPr lang="en-US" sz="1500" b="1" dirty="0">
-                <a:solidFill>
-                  <a:srgbClr val="516673"/>
-                </a:solidFill>
-                <a:latin typeface="Arial" pitchFamily="34" charset="0"/>
-                <a:ea typeface="Arial" pitchFamily="34" charset="-122"/>
-                <a:cs typeface="Arial" pitchFamily="34" charset="-120"/>
+              <a:rPr lang="en-US" sz="1500" b="1" dirty="0" u="sng">
+                <a:solidFill>
+                  <a:srgbClr val="007C9F"/>
+                </a:solidFill>
+                <a:latin typeface="Arial" pitchFamily="34" charset="0"/>
+                <a:ea typeface="Arial" pitchFamily="34" charset="-122"/>
+                <a:cs typeface="Arial" pitchFamily="34" charset="-120"/>
+                <a:hlinkClick r:id="rId3"/>
               </a:rPr>
               <a:t>CP-CAT-02</a:t>
             </a:r>
@@ -15949,6 +16951,10 @@
             <a:prstDash val="solid"/>
           </a:ln>
         </p:spPr>
+        <p:txBody>
+          <a:bodyPr/>
+          <a:p/>
+        </p:txBody>
       </p:sp>
       <p:sp>
         <p:nvSpPr>
@@ -15971,6 +16977,10 @@
           </a:solidFill>
           <a:ln/>
         </p:spPr>
+        <p:txBody>
+          <a:bodyPr/>
+          <a:p/>
+        </p:txBody>
       </p:sp>
       <p:sp>
         <p:nvSpPr>
@@ -16042,13 +17052,14 @@
               <a:buNone/>
             </a:pPr>
             <a:r>
-              <a:rPr lang="en-US" sz="1500" b="1" dirty="0">
-                <a:solidFill>
-                  <a:srgbClr val="516673"/>
-                </a:solidFill>
-                <a:latin typeface="Arial" pitchFamily="34" charset="0"/>
-                <a:ea typeface="Arial" pitchFamily="34" charset="-122"/>
-                <a:cs typeface="Arial" pitchFamily="34" charset="-120"/>
+              <a:rPr lang="en-US" sz="1500" b="1" dirty="0" u="sng">
+                <a:solidFill>
+                  <a:srgbClr val="007C9F"/>
+                </a:solidFill>
+                <a:latin typeface="Arial" pitchFamily="34" charset="0"/>
+                <a:ea typeface="Arial" pitchFamily="34" charset="-122"/>
+                <a:cs typeface="Arial" pitchFamily="34" charset="-120"/>
+                <a:hlinkClick r:id="rId4"/>
               </a:rPr>
               <a:t>CP-PRO-01</a:t>
             </a:r>
@@ -16124,6 +17135,10 @@
             <a:prstDash val="solid"/>
           </a:ln>
         </p:spPr>
+        <p:txBody>
+          <a:bodyPr/>
+          <a:p/>
+        </p:txBody>
       </p:sp>
       <p:sp>
         <p:nvSpPr>
@@ -16146,6 +17161,10 @@
           </a:solidFill>
           <a:ln/>
         </p:spPr>
+        <p:txBody>
+          <a:bodyPr/>
+          <a:p/>
+        </p:txBody>
       </p:sp>
       <p:sp>
         <p:nvSpPr>
@@ -16217,13 +17236,14 @@
               <a:buNone/>
             </a:pPr>
             <a:r>
-              <a:rPr lang="en-US" sz="1500" b="1" dirty="0">
-                <a:solidFill>
-                  <a:srgbClr val="516673"/>
-                </a:solidFill>
-                <a:latin typeface="Arial" pitchFamily="34" charset="0"/>
-                <a:ea typeface="Arial" pitchFamily="34" charset="-122"/>
-                <a:cs typeface="Arial" pitchFamily="34" charset="-120"/>
+              <a:rPr lang="en-US" sz="1500" b="1" dirty="0" u="sng">
+                <a:solidFill>
+                  <a:srgbClr val="007C9F"/>
+                </a:solidFill>
+                <a:latin typeface="Arial" pitchFamily="34" charset="0"/>
+                <a:ea typeface="Arial" pitchFamily="34" charset="-122"/>
+                <a:cs typeface="Arial" pitchFamily="34" charset="-120"/>
+                <a:hlinkClick r:id="rId5"/>
               </a:rPr>
               <a:t>CP-PRO-02</a:t>
             </a:r>
@@ -16299,6 +17319,10 @@
             <a:prstDash val="solid"/>
           </a:ln>
         </p:spPr>
+        <p:txBody>
+          <a:bodyPr/>
+          <a:p/>
+        </p:txBody>
       </p:sp>
       <p:sp>
         <p:nvSpPr>
@@ -16321,6 +17345,10 @@
           </a:solidFill>
           <a:ln/>
         </p:spPr>
+        <p:txBody>
+          <a:bodyPr/>
+          <a:p/>
+        </p:txBody>
       </p:sp>
       <p:sp>
         <p:nvSpPr>
@@ -16391,6 +17419,19 @@
               </a:lnSpc>
               <a:buNone/>
             </a:pPr>
+            <a:endParaRPr lang="en-US" sz="1500" dirty="0"/>
+            <a:r>
+              <a:rPr lang="en-US" sz="1500" b="1" dirty="0" u="sng">
+                <a:solidFill>
+                  <a:srgbClr val="007C9F"/>
+                </a:solidFill>
+                <a:latin typeface="Arial" pitchFamily="34" charset="0"/>
+                <a:ea typeface="Arial" pitchFamily="34" charset="-122"/>
+                <a:cs typeface="Arial" pitchFamily="34" charset="-120"/>
+                <a:hlinkClick r:id="rId6"/>
+              </a:rPr>
+              <a:t>CP-CUP-01</a:t>
+            </a:r>
             <a:r>
               <a:rPr lang="en-US" sz="1500" b="1" dirty="0">
                 <a:solidFill>
@@ -16400,9 +17441,20 @@
                 <a:ea typeface="Arial" pitchFamily="34" charset="-122"/>
                 <a:cs typeface="Arial" pitchFamily="34" charset="-120"/>
               </a:rPr>
-              <a:t>CP-CUP-01 / CP-CUP-02</a:t>
-            </a:r>
-            <a:endParaRPr lang="en-US" sz="1500" dirty="0"/>
+              <a:t> / </a:t>
+            </a:r>
+            <a:r>
+              <a:rPr lang="en-US" sz="1500" b="1" dirty="0" u="sng">
+                <a:solidFill>
+                  <a:srgbClr val="007C9F"/>
+                </a:solidFill>
+                <a:latin typeface="Arial" pitchFamily="34" charset="0"/>
+                <a:ea typeface="Arial" pitchFamily="34" charset="-122"/>
+                <a:cs typeface="Arial" pitchFamily="34" charset="-120"/>
+                <a:hlinkClick r:id="rId7"/>
+              </a:rPr>
+              <a:t>CP-CUP-02</a:t>
+            </a:r>
           </a:p>
         </p:txBody>
       </p:sp>
@@ -16469,6 +17521,10 @@
           </a:solidFill>
           <a:ln/>
         </p:spPr>
+        <p:txBody>
+          <a:bodyPr/>
+          <a:p/>
+        </p:txBody>
       </p:sp>
       <p:sp>
         <p:nvSpPr>
@@ -16491,6 +17547,10 @@
           </a:solidFill>
           <a:ln/>
         </p:spPr>
+        <p:txBody>
+          <a:bodyPr/>
+          <a:p/>
+        </p:txBody>
       </p:sp>
       <p:sp>
         <p:nvSpPr>
@@ -16573,6 +17633,41 @@
               <a:t>Sin su variante positiva obligatoria, un caso no se aprueba.</a:t>
             </a:r>
             <a:endParaRPr lang="en-US" sz="1700" dirty="0"/>
+          </a:p>
+        </p:txBody>
+      </p:sp>
+      <p:sp>
+        <p:nvSpPr>
+          <p:cNvPr id="30" name="TextBox 29"/>
+          <p:cNvSpPr txBox="1"/>
+          <p:nvPr/>
+        </p:nvSpPr>
+        <p:spPr>
+          <a:xfrm>
+            <a:off x="457200" y="6473952"/>
+            <a:ext cx="11277295" cy="256032"/>
+          </a:xfrm>
+          <a:prstGeom prst="rect">
+            <a:avLst/>
+          </a:prstGeom>
+          <a:noFill/>
+        </p:spPr>
+        <p:txBody>
+          <a:bodyPr wrap="none">
+            <a:spAutoFit/>
+          </a:bodyPr>
+          <a:lstStyle/>
+          <a:p>
+            <a:r>
+              <a:rPr sz="1200">
+                <a:solidFill>
+                  <a:srgbClr val="516673"/>
+                </a:solidFill>
+                <a:latin typeface="Arial"/>
+                <a:hlinkClick r:id="rId3"/>
+              </a:rPr>
+              <a:t>▸ Informe §3.2 Fichas de diseño · p. 12</a:t>
+            </a:r>
           </a:p>
         </p:txBody>
       </p:sp>
@@ -16627,6 +17722,10 @@
           </a:solidFill>
           <a:ln/>
         </p:spPr>
+        <p:txBody>
+          <a:bodyPr/>
+          <a:p/>
+        </p:txBody>
       </p:sp>
       <p:sp>
         <p:nvSpPr>
@@ -16697,6 +17796,19 @@
               </a:lnSpc>
               <a:buNone/>
             </a:pPr>
+            <a:endParaRPr lang="en-US" sz="2800" dirty="0"/>
+            <a:r>
+              <a:rPr lang="en-US" sz="2800" b="1" dirty="0" u="sng">
+                <a:solidFill>
+                  <a:srgbClr val="007C9F"/>
+                </a:solidFill>
+                <a:latin typeface="Arial" pitchFamily="34" charset="0"/>
+                <a:ea typeface="Arial" pitchFamily="34" charset="-122"/>
+                <a:cs typeface="Arial" pitchFamily="34" charset="-120"/>
+                <a:hlinkClick r:id="rId3"/>
+              </a:rPr>
+              <a:t>DEF-01</a:t>
+            </a:r>
             <a:r>
               <a:rPr lang="en-US" sz="2800" b="1" dirty="0">
                 <a:solidFill>
@@ -16706,9 +17818,8 @@
                 <a:ea typeface="Arial" pitchFamily="34" charset="-122"/>
                 <a:cs typeface="Arial" pitchFamily="34" charset="-120"/>
               </a:rPr>
-              <a:t>DEF-01 · defecto abierto</a:t>
-            </a:r>
-            <a:endParaRPr lang="en-US" sz="2800" dirty="0"/>
+              <a:t> · defecto abierto</a:t>
+            </a:r>
           </a:p>
         </p:txBody>
       </p:sp>
@@ -16780,6 +17891,10 @@
             <a:prstDash val="solid"/>
           </a:ln>
         </p:spPr>
+        <p:txBody>
+          <a:bodyPr/>
+          <a:p/>
+        </p:txBody>
       </p:sp>
       <p:sp>
         <p:nvSpPr>
@@ -16849,6 +17964,10 @@
             <a:prstDash val="solid"/>
           </a:ln>
         </p:spPr>
+        <p:txBody>
+          <a:bodyPr/>
+          <a:p/>
+        </p:txBody>
       </p:sp>
       <p:sp>
         <p:nvSpPr>
@@ -16960,6 +18079,10 @@
             <a:prstDash val="solid"/>
           </a:ln>
         </p:spPr>
+        <p:txBody>
+          <a:bodyPr/>
+          <a:p/>
+        </p:txBody>
       </p:sp>
       <p:sp>
         <p:nvSpPr>
@@ -17113,6 +18236,10 @@
             <a:prstDash val="solid"/>
           </a:ln>
         </p:spPr>
+        <p:txBody>
+          <a:bodyPr/>
+          <a:p/>
+        </p:txBody>
       </p:sp>
       <p:sp>
         <p:nvSpPr>
@@ -17219,6 +18346,10 @@
           </a:solidFill>
           <a:ln/>
         </p:spPr>
+        <p:txBody>
+          <a:bodyPr/>
+          <a:p/>
+        </p:txBody>
       </p:sp>
       <p:sp>
         <p:nvSpPr>
@@ -17325,6 +18456,10 @@
           </a:solidFill>
           <a:ln/>
         </p:spPr>
+        <p:txBody>
+          <a:bodyPr/>
+          <a:p/>
+        </p:txBody>
       </p:sp>
       <p:sp>
         <p:nvSpPr>
@@ -17431,6 +18566,10 @@
           </a:solidFill>
           <a:ln/>
         </p:spPr>
+        <p:txBody>
+          <a:bodyPr/>
+          <a:p/>
+        </p:txBody>
       </p:sp>
       <p:sp>
         <p:nvSpPr>
@@ -17555,6 +18694,41 @@
               <a:t>Eco Tax: hipótesis, no causa confirmada. No inspeccionamos código.</a:t>
             </a:r>
             <a:endParaRPr lang="en-US" sz="1600" dirty="0"/>
+          </a:p>
+        </p:txBody>
+      </p:sp>
+      <p:sp>
+        <p:nvSpPr>
+          <p:cNvPr id="28" name="TextBox 27"/>
+          <p:cNvSpPr txBox="1"/>
+          <p:nvPr/>
+        </p:nvSpPr>
+        <p:spPr>
+          <a:xfrm>
+            <a:off x="457200" y="6473952"/>
+            <a:ext cx="11277295" cy="256032"/>
+          </a:xfrm>
+          <a:prstGeom prst="rect">
+            <a:avLst/>
+          </a:prstGeom>
+          <a:noFill/>
+        </p:spPr>
+        <p:txBody>
+          <a:bodyPr wrap="none">
+            <a:spAutoFit/>
+          </a:bodyPr>
+          <a:lstStyle/>
+          <a:p>
+            <a:r>
+              <a:rPr sz="1200">
+                <a:solidFill>
+                  <a:srgbClr val="516673"/>
+                </a:solidFill>
+                <a:latin typeface="Arial"/>
+                <a:hlinkClick r:id="rId3"/>
+              </a:rPr>
+              <a:t>▸ Informe §4.5 Hallazgos · p. 32</a:t>
+            </a:r>
           </a:p>
         </p:txBody>
       </p:sp>
@@ -17609,6 +18783,10 @@
           </a:solidFill>
           <a:ln/>
         </p:spPr>
+        <p:txBody>
+          <a:bodyPr/>
+          <a:p/>
+        </p:txBody>
       </p:sp>
       <p:sp>
         <p:nvSpPr>
@@ -17762,6 +18940,10 @@
             <a:prstDash val="solid"/>
           </a:ln>
         </p:spPr>
+        <p:txBody>
+          <a:bodyPr/>
+          <a:p/>
+        </p:txBody>
       </p:sp>
       <p:sp>
         <p:nvSpPr>
@@ -17873,6 +19055,10 @@
             <a:prstDash val="solid"/>
           </a:ln>
         </p:spPr>
+        <p:txBody>
+          <a:bodyPr/>
+          <a:p/>
+        </p:txBody>
       </p:sp>
       <p:sp>
         <p:nvSpPr>
@@ -17984,6 +19170,10 @@
             <a:prstDash val="solid"/>
           </a:ln>
         </p:spPr>
+        <p:txBody>
+          <a:bodyPr/>
+          <a:p/>
+        </p:txBody>
       </p:sp>
       <p:sp>
         <p:nvSpPr>
@@ -18141,6 +19331,10 @@
           </a:solidFill>
           <a:ln/>
         </p:spPr>
+        <p:txBody>
+          <a:bodyPr/>
+          <a:p/>
+        </p:txBody>
       </p:sp>
       <p:sp>
         <p:nvSpPr>
@@ -18163,6 +19357,10 @@
           </a:solidFill>
           <a:ln/>
         </p:spPr>
+        <p:txBody>
+          <a:bodyPr/>
+          <a:p/>
+        </p:txBody>
       </p:sp>
       <p:sp>
         <p:nvSpPr>
@@ -18233,6 +19431,19 @@
               </a:lnSpc>
               <a:buNone/>
             </a:pPr>
+            <a:endParaRPr lang="en-US" sz="1700" dirty="0"/>
+            <a:r>
+              <a:rPr lang="en-US" sz="1700" b="1" dirty="0" u="sng">
+                <a:solidFill>
+                  <a:srgbClr val="007C9F"/>
+                </a:solidFill>
+                <a:latin typeface="Arial" pitchFamily="34" charset="0"/>
+                <a:ea typeface="Arial" pitchFamily="34" charset="-122"/>
+                <a:cs typeface="Arial" pitchFamily="34" charset="-120"/>
+                <a:hlinkClick r:id="rId3"/>
+              </a:rPr>
+              <a:t>CP-CAR-02</a:t>
+            </a:r>
             <a:r>
               <a:rPr lang="en-US" sz="1700" b="1" dirty="0">
                 <a:solidFill>
@@ -18242,9 +19453,8 @@
                 <a:ea typeface="Arial" pitchFamily="34" charset="-122"/>
                 <a:cs typeface="Arial" pitchFamily="34" charset="-120"/>
               </a:rPr>
-              <a:t>CP-CAR-02 · integridad de cantidades y frontera de stock</a:t>
-            </a:r>
-            <a:endParaRPr lang="en-US" sz="1700" dirty="0"/>
+              <a:t> · integridad de cantidades y frontera de stock</a:t>
+            </a:r>
           </a:p>
         </p:txBody>
       </p:sp>
@@ -18275,6 +19485,7 @@
               </a:lnSpc>
               <a:buNone/>
             </a:pPr>
+            <a:endParaRPr lang="en-US" sz="1600" dirty="0"/>
             <a:r>
               <a:rPr lang="en-US" sz="1600" dirty="0">
                 <a:solidFill>
@@ -18284,9 +19495,31 @@
                 <a:ea typeface="Arial" pitchFamily="34" charset="-122"/>
                 <a:cs typeface="Arial" pitchFamily="34" charset="-120"/>
               </a:rPr>
-              <a:t>No cubre el cálculo monetario (CP-CAR-01, Falló) ni una compra completada.</a:t>
-            </a:r>
-            <a:endParaRPr lang="en-US" sz="1600" dirty="0"/>
+              <a:t>No cubre el cálculo monetario (</a:t>
+            </a:r>
+            <a:r>
+              <a:rPr lang="en-US" sz="1600" dirty="0" u="sng">
+                <a:solidFill>
+                  <a:srgbClr val="007C9F"/>
+                </a:solidFill>
+                <a:latin typeface="Arial" pitchFamily="34" charset="0"/>
+                <a:ea typeface="Arial" pitchFamily="34" charset="-122"/>
+                <a:cs typeface="Arial" pitchFamily="34" charset="-120"/>
+                <a:hlinkClick r:id="rId4"/>
+              </a:rPr>
+              <a:t>CP-CAR-01</a:t>
+            </a:r>
+            <a:r>
+              <a:rPr lang="en-US" sz="1600" dirty="0">
+                <a:solidFill>
+                  <a:srgbClr val="142D3D"/>
+                </a:solidFill>
+                <a:latin typeface="Arial" pitchFamily="34" charset="0"/>
+                <a:ea typeface="Arial" pitchFamily="34" charset="-122"/>
+                <a:cs typeface="Arial" pitchFamily="34" charset="-120"/>
+              </a:rPr>
+              <a:t>, Falló) ni una compra completada.</a:t>
+            </a:r>
           </a:p>
         </p:txBody>
       </p:sp>
@@ -18329,6 +19562,41 @@
               <a:t>Bloque de Franco · 7 casos Alta:  3 Pasó · 1 Falló · 3 Bloqueado</a:t>
             </a:r>
             <a:endParaRPr lang="en-US" sz="1600" dirty="0"/>
+          </a:p>
+        </p:txBody>
+      </p:sp>
+      <p:sp>
+        <p:nvSpPr>
+          <p:cNvPr id="21" name="TextBox 20"/>
+          <p:cNvSpPr txBox="1"/>
+          <p:nvPr/>
+        </p:nvSpPr>
+        <p:spPr>
+          <a:xfrm>
+            <a:off x="457200" y="6473952"/>
+            <a:ext cx="11277295" cy="256032"/>
+          </a:xfrm>
+          <a:prstGeom prst="rect">
+            <a:avLst/>
+          </a:prstGeom>
+          <a:noFill/>
+        </p:spPr>
+        <p:txBody>
+          <a:bodyPr wrap="none">
+            <a:spAutoFit/>
+          </a:bodyPr>
+          <a:lstStyle/>
+          <a:p>
+            <a:r>
+              <a:rPr sz="1200">
+                <a:solidFill>
+                  <a:srgbClr val="516673"/>
+                </a:solidFill>
+                <a:latin typeface="Arial"/>
+                <a:hlinkClick r:id="rId3"/>
+              </a:rPr>
+              <a:t>▸ Informe §3.2 CP-CAR-02 · p. 16</a:t>
+            </a:r>
           </a:p>
         </p:txBody>
       </p:sp>
@@ -18383,6 +19651,10 @@
           </a:solidFill>
           <a:ln/>
         </p:spPr>
+        <p:txBody>
+          <a:bodyPr/>
+          <a:p/>
+        </p:txBody>
       </p:sp>
       <p:sp>
         <p:nvSpPr>
@@ -18453,6 +19725,19 @@
               </a:lnSpc>
               <a:buNone/>
             </a:pPr>
+            <a:endParaRPr lang="en-US" sz="2800" dirty="0"/>
+            <a:r>
+              <a:rPr lang="en-US" sz="2800" b="1" dirty="0" u="sng">
+                <a:solidFill>
+                  <a:srgbClr val="007C9F"/>
+                </a:solidFill>
+                <a:latin typeface="Arial" pitchFamily="34" charset="0"/>
+                <a:ea typeface="Arial" pitchFamily="34" charset="-122"/>
+                <a:cs typeface="Arial" pitchFamily="34" charset="-120"/>
+                <a:hlinkClick r:id="rId3"/>
+              </a:rPr>
+              <a:t>DEF-04</a:t>
+            </a:r>
             <a:r>
               <a:rPr lang="en-US" sz="2800" b="1" dirty="0">
                 <a:solidFill>
@@ -18462,9 +19747,8 @@
                 <a:ea typeface="Arial" pitchFamily="34" charset="-122"/>
                 <a:cs typeface="Arial" pitchFamily="34" charset="-120"/>
               </a:rPr>
-              <a:t>DEF-04 · defecto abierto</a:t>
-            </a:r>
-            <a:endParaRPr lang="en-US" sz="2800" dirty="0"/>
+              <a:t> · defecto abierto</a:t>
+            </a:r>
           </a:p>
         </p:txBody>
       </p:sp>
@@ -18536,6 +19820,10 @@
             <a:prstDash val="solid"/>
           </a:ln>
         </p:spPr>
+        <p:txBody>
+          <a:bodyPr/>
+          <a:p/>
+        </p:txBody>
       </p:sp>
       <p:sp>
         <p:nvSpPr>
@@ -18605,6 +19893,10 @@
             <a:prstDash val="solid"/>
           </a:ln>
         </p:spPr>
+        <p:txBody>
+          <a:bodyPr/>
+          <a:p/>
+        </p:txBody>
       </p:sp>
       <p:sp>
         <p:nvSpPr>
@@ -18753,6 +20045,10 @@
           </a:solidFill>
           <a:ln/>
         </p:spPr>
+        <p:txBody>
+          <a:bodyPr/>
+          <a:p/>
+        </p:txBody>
       </p:sp>
       <p:sp>
         <p:nvSpPr>
@@ -18864,6 +20160,10 @@
             <a:prstDash val="solid"/>
           </a:ln>
         </p:spPr>
+        <p:txBody>
+          <a:bodyPr/>
+          <a:p/>
+        </p:txBody>
       </p:sp>
       <p:sp>
         <p:nvSpPr>
@@ -18975,6 +20275,10 @@
             <a:prstDash val="solid"/>
           </a:ln>
         </p:spPr>
+        <p:txBody>
+          <a:bodyPr/>
+          <a:p/>
+        </p:txBody>
       </p:sp>
       <p:sp>
         <p:nvSpPr>
@@ -19086,6 +20390,10 @@
             <a:prstDash val="solid"/>
           </a:ln>
         </p:spPr>
+        <p:txBody>
+          <a:bodyPr/>
+          <a:p/>
+        </p:txBody>
       </p:sp>
       <p:sp>
         <p:nvSpPr>
@@ -19192,6 +20500,10 @@
           </a:solidFill>
           <a:ln/>
         </p:spPr>
+        <p:txBody>
+          <a:bodyPr/>
+          <a:p/>
+        </p:txBody>
       </p:sp>
       <p:sp>
         <p:nvSpPr>
@@ -19274,6 +20586,41 @@
               <a:t>Cash on Delivery habilitado en el panel: pista, no causa confirmada.</a:t>
             </a:r>
             <a:endParaRPr lang="en-US" sz="1500" dirty="0"/>
+          </a:p>
+        </p:txBody>
+      </p:sp>
+      <p:sp>
+        <p:nvSpPr>
+          <p:cNvPr id="27" name="TextBox 26"/>
+          <p:cNvSpPr txBox="1"/>
+          <p:nvPr/>
+        </p:nvSpPr>
+        <p:spPr>
+          <a:xfrm>
+            <a:off x="457200" y="6473952"/>
+            <a:ext cx="11277295" cy="256032"/>
+          </a:xfrm>
+          <a:prstGeom prst="rect">
+            <a:avLst/>
+          </a:prstGeom>
+          <a:noFill/>
+        </p:spPr>
+        <p:txBody>
+          <a:bodyPr wrap="none">
+            <a:spAutoFit/>
+          </a:bodyPr>
+          <a:lstStyle/>
+          <a:p>
+            <a:r>
+              <a:rPr sz="1200">
+                <a:solidFill>
+                  <a:srgbClr val="516673"/>
+                </a:solidFill>
+                <a:latin typeface="Arial"/>
+                <a:hlinkClick r:id="rId3"/>
+              </a:rPr>
+              <a:t>▸ Informe §4.5 Hallazgos · p. 32</a:t>
+            </a:r>
           </a:p>
         </p:txBody>
       </p:sp>

</xml_diff>